<commit_message>
fix: remove unused variables that cause build failure
</commit_message>
<xml_diff>
--- a/msppt.pptx
+++ b/msppt.pptx
@@ -3548,7 +3548,7 @@
         </p:nvSpPr>
         <p:spPr>
           <a:xfrm>
-            <a:off x="457200" y="868680"/>
+            <a:off x="457200" y="594360"/>
             <a:ext cx="9144000" cy="640080"/>
           </a:xfrm>
           <a:prstGeom prst="rect">
@@ -3565,7 +3565,7 @@
               <a:buNone/>
             </a:pPr>
             <a:r>
-              <a:rPr lang="en-US" sz="3000" b="1" dirty="0">
+              <a:rPr lang="en-US" sz="2400" b="1" dirty="0">
                 <a:solidFill>
                   <a:srgbClr val="16231D"/>
                 </a:solidFill>
@@ -3575,7 +3575,7 @@
               </a:rPr>
               <a:t>Impact &amp; Benefits</a:t>
             </a:r>
-            <a:endParaRPr lang="en-US" sz="3000" dirty="0"/>
+            <a:endParaRPr lang="en-US" sz="2400" dirty="0"/>
           </a:p>
         </p:txBody>
       </p:sp>
@@ -3587,8 +3587,8 @@
         </p:nvSpPr>
         <p:spPr>
           <a:xfrm>
-            <a:off x="457200" y="1691640"/>
-            <a:ext cx="3611880" cy="1737360"/>
+            <a:off x="458644" y="1319022"/>
+            <a:ext cx="3611880" cy="1364421"/>
           </a:xfrm>
           <a:prstGeom prst="roundRect">
             <a:avLst>
@@ -3611,7 +3611,7 @@
           <a:bodyPr/>
           <a:lstStyle/>
           <a:p>
-            <a:endParaRPr lang="en-IN"/>
+            <a:endParaRPr lang="en-IN" dirty="0"/>
           </a:p>
         </p:txBody>
       </p:sp>
@@ -3623,7 +3623,7 @@
         </p:nvSpPr>
         <p:spPr>
           <a:xfrm>
-            <a:off x="713232" y="1920240"/>
+            <a:off x="597103" y="1360771"/>
             <a:ext cx="530352" cy="530352"/>
           </a:xfrm>
           <a:prstGeom prst="ellipse">
@@ -3658,7 +3658,7 @@
         </p:blipFill>
         <p:spPr>
           <a:xfrm>
-            <a:off x="851124" y="2058132"/>
+            <a:off x="713232" y="1498662"/>
             <a:ext cx="254569" cy="254569"/>
           </a:xfrm>
           <a:prstGeom prst="rect">
@@ -3674,7 +3674,7 @@
         </p:nvSpPr>
         <p:spPr>
           <a:xfrm>
-            <a:off x="713232" y="2542032"/>
+            <a:off x="1289064" y="1392174"/>
             <a:ext cx="3108960" cy="457200"/>
           </a:xfrm>
           <a:prstGeom prst="rect">
@@ -3713,7 +3713,7 @@
         </p:nvSpPr>
         <p:spPr>
           <a:xfrm>
-            <a:off x="713232" y="2999232"/>
+            <a:off x="1005840" y="2035493"/>
             <a:ext cx="3108960" cy="365760"/>
           </a:xfrm>
           <a:prstGeom prst="rect">
@@ -3752,8 +3752,8 @@
         </p:nvSpPr>
         <p:spPr>
           <a:xfrm>
-            <a:off x="4297680" y="1691640"/>
-            <a:ext cx="3611880" cy="1737360"/>
+            <a:off x="4248100" y="1150924"/>
+            <a:ext cx="3611880" cy="1480397"/>
           </a:xfrm>
           <a:prstGeom prst="roundRect">
             <a:avLst>
@@ -3776,7 +3776,7 @@
           <a:bodyPr/>
           <a:lstStyle/>
           <a:p>
-            <a:endParaRPr lang="en-IN"/>
+            <a:endParaRPr lang="en-IN" dirty="0"/>
           </a:p>
         </p:txBody>
       </p:sp>
@@ -3788,7 +3788,7 @@
         </p:nvSpPr>
         <p:spPr>
           <a:xfrm>
-            <a:off x="4553712" y="1920240"/>
+            <a:off x="4422146" y="1230733"/>
             <a:ext cx="530352" cy="530352"/>
           </a:xfrm>
           <a:prstGeom prst="ellipse">
@@ -3803,7 +3803,7 @@
           <a:bodyPr/>
           <a:lstStyle/>
           <a:p>
-            <a:endParaRPr lang="en-IN"/>
+            <a:endParaRPr lang="en-IN" dirty="0"/>
           </a:p>
         </p:txBody>
       </p:sp>
@@ -3823,7 +3823,7 @@
         </p:blipFill>
         <p:spPr>
           <a:xfrm>
-            <a:off x="4691604" y="2058132"/>
+            <a:off x="4551701" y="1331581"/>
             <a:ext cx="254569" cy="254569"/>
           </a:xfrm>
           <a:prstGeom prst="rect">
@@ -3839,8 +3839,8 @@
         </p:nvSpPr>
         <p:spPr>
           <a:xfrm>
-            <a:off x="4553712" y="2542032"/>
-            <a:ext cx="3108960" cy="457200"/>
+            <a:off x="5157892" y="1226091"/>
+            <a:ext cx="1046449" cy="457200"/>
           </a:xfrm>
           <a:prstGeom prst="rect">
             <a:avLst/>
@@ -3878,7 +3878,7 @@
         </p:nvSpPr>
         <p:spPr>
           <a:xfrm>
-            <a:off x="4553712" y="2999232"/>
+            <a:off x="4716878" y="2116836"/>
             <a:ext cx="3108960" cy="365760"/>
           </a:xfrm>
           <a:prstGeom prst="rect">
@@ -3917,8 +3917,8 @@
         </p:nvSpPr>
         <p:spPr>
           <a:xfrm>
-            <a:off x="8138160" y="1691640"/>
-            <a:ext cx="3611880" cy="1737360"/>
+            <a:off x="8022416" y="1127192"/>
+            <a:ext cx="3611880" cy="1461026"/>
           </a:xfrm>
           <a:prstGeom prst="roundRect">
             <a:avLst>
@@ -3941,7 +3941,7 @@
           <a:bodyPr/>
           <a:lstStyle/>
           <a:p>
-            <a:endParaRPr lang="en-IN"/>
+            <a:endParaRPr lang="en-IN" dirty="0"/>
           </a:p>
         </p:txBody>
       </p:sp>
@@ -3953,7 +3953,7 @@
         </p:nvSpPr>
         <p:spPr>
           <a:xfrm>
-            <a:off x="8394192" y="1920240"/>
+            <a:off x="8097251" y="1193689"/>
             <a:ext cx="530352" cy="530352"/>
           </a:xfrm>
           <a:prstGeom prst="ellipse">
@@ -3968,7 +3968,7 @@
           <a:bodyPr/>
           <a:lstStyle/>
           <a:p>
-            <a:endParaRPr lang="en-IN"/>
+            <a:endParaRPr lang="en-IN" dirty="0"/>
           </a:p>
         </p:txBody>
       </p:sp>
@@ -3988,7 +3988,7 @@
         </p:blipFill>
         <p:spPr>
           <a:xfrm>
-            <a:off x="8532084" y="2058132"/>
+            <a:off x="8242833" y="1314676"/>
             <a:ext cx="254569" cy="254569"/>
           </a:xfrm>
           <a:prstGeom prst="rect">
@@ -4004,7 +4004,7 @@
         </p:nvSpPr>
         <p:spPr>
           <a:xfrm>
-            <a:off x="8394192" y="2542032"/>
+            <a:off x="8769772" y="1173213"/>
             <a:ext cx="3108960" cy="457200"/>
           </a:xfrm>
           <a:prstGeom prst="rect">
@@ -4043,7 +4043,7 @@
         </p:nvSpPr>
         <p:spPr>
           <a:xfrm>
-            <a:off x="8394192" y="2999232"/>
+            <a:off x="8583328" y="2014937"/>
             <a:ext cx="3108960" cy="365760"/>
           </a:xfrm>
           <a:prstGeom prst="rect">
@@ -4082,8 +4082,8 @@
         </p:nvSpPr>
         <p:spPr>
           <a:xfrm>
-            <a:off x="457200" y="3657600"/>
-            <a:ext cx="5394960" cy="2514600"/>
+            <a:off x="432736" y="3183974"/>
+            <a:ext cx="5394960" cy="3445426"/>
           </a:xfrm>
           <a:prstGeom prst="roundRect">
             <a:avLst>
@@ -4111,7 +4111,7 @@
         </p:nvSpPr>
         <p:spPr>
           <a:xfrm>
-            <a:off x="731520" y="3886200"/>
+            <a:off x="490118" y="3183974"/>
             <a:ext cx="502920" cy="502920"/>
           </a:xfrm>
           <a:prstGeom prst="ellipse">
@@ -4126,7 +4126,7 @@
           <a:bodyPr/>
           <a:lstStyle/>
           <a:p>
-            <a:endParaRPr lang="en-IN"/>
+            <a:endParaRPr lang="en-IN" dirty="0"/>
           </a:p>
         </p:txBody>
       </p:sp>
@@ -4146,7 +4146,7 @@
         </p:blipFill>
         <p:spPr>
           <a:xfrm>
-            <a:off x="862279" y="4016959"/>
+            <a:off x="620877" y="3348885"/>
             <a:ext cx="241402" cy="241402"/>
           </a:xfrm>
           <a:prstGeom prst="rect">
@@ -4162,7 +4162,7 @@
         </p:nvSpPr>
         <p:spPr>
           <a:xfrm>
-            <a:off x="1371600" y="3886200"/>
+            <a:off x="1289064" y="2873989"/>
             <a:ext cx="4206240" cy="502920"/>
           </a:xfrm>
           <a:prstGeom prst="rect">
@@ -4201,7 +4201,7 @@
         </p:nvSpPr>
         <p:spPr>
           <a:xfrm>
-            <a:off x="731520" y="4572000"/>
+            <a:off x="1251857" y="4129447"/>
             <a:ext cx="4846320" cy="1554480"/>
           </a:xfrm>
           <a:prstGeom prst="rect">
@@ -4345,8 +4345,8 @@
         </p:nvSpPr>
         <p:spPr>
           <a:xfrm>
-            <a:off x="6309360" y="3657600"/>
-            <a:ext cx="5394960" cy="2514600"/>
+            <a:off x="6280394" y="3227634"/>
+            <a:ext cx="5394960" cy="3246317"/>
           </a:xfrm>
           <a:prstGeom prst="roundRect">
             <a:avLst>
@@ -4362,7 +4362,7 @@
           <a:bodyPr/>
           <a:lstStyle/>
           <a:p>
-            <a:endParaRPr lang="en-IN"/>
+            <a:endParaRPr lang="en-IN" dirty="0"/>
           </a:p>
         </p:txBody>
       </p:sp>
@@ -4425,7 +4425,7 @@
         </p:nvSpPr>
         <p:spPr>
           <a:xfrm>
-            <a:off x="7223760" y="3886200"/>
+            <a:off x="6835140" y="2795739"/>
             <a:ext cx="4206240" cy="502920"/>
           </a:xfrm>
           <a:prstGeom prst="rect">
@@ -4464,7 +4464,7 @@
         </p:nvSpPr>
         <p:spPr>
           <a:xfrm>
-            <a:off x="6583680" y="4572000"/>
+            <a:off x="7119281" y="4090857"/>
             <a:ext cx="4846320" cy="1554480"/>
           </a:xfrm>
           <a:prstGeom prst="rect">
@@ -10056,7 +10056,7 @@
         </p:blipFill>
         <p:spPr>
           <a:xfrm>
-            <a:off x="953636" y="3200948"/>
+            <a:off x="6046688" y="341895"/>
             <a:ext cx="3053357" cy="2861523"/>
           </a:xfrm>
           <a:prstGeom prst="rect">

</xml_diff>